<commit_message>
Finalize submission metadata + idea deck
Fill team identity (Hunter Association / Shubham Mittal), contact, live
GitHub + Streamlit sandbox URLs across submission_metadata.yaml and the
idea-submission deck.

Co-Authored-By: Claude Opus 4.8 (1M context) <noreply@anthropic.com>
</commit_message>
<xml_diff>
--- a/Idea Submission - EvidenceRank.pptx
+++ b/Idea Submission - EvidenceRank.pptx
@@ -3187,10 +3187,10 @@
             <a:r>
               <a:rPr sz="1600">
                 <a:solidFill>
-                  <a:srgbClr val="C0392B"/>
-                </a:solidFill>
-              </a:rPr>
-              <a:t>&lt;&lt;FILL: your registered team name&gt;&gt;</a:t>
+                  <a:srgbClr val="EAF1F8"/>
+                </a:solidFill>
+              </a:rPr>
+              <a:t>Hunter Association</a:t>
             </a:r>
           </a:p>
           <a:p>
@@ -3233,10 +3233,10 @@
             <a:r>
               <a:rPr sz="1600">
                 <a:solidFill>
-                  <a:srgbClr val="C0392B"/>
-                </a:solidFill>
-              </a:rPr>
-              <a:t>&lt;&lt;FILL: team leader name&gt;&gt;</a:t>
+                  <a:srgbClr val="EAF1F8"/>
+                </a:solidFill>
+              </a:rPr>
+              <a:t>Shubham Mittal</a:t>
             </a:r>
           </a:p>
         </p:txBody>
@@ -3383,10 +3383,10 @@
             <a:r>
               <a:rPr sz="1600" b="1">
                 <a:solidFill>
-                  <a:srgbClr val="C0392B"/>
-                </a:solidFill>
-              </a:rPr>
-              <a:t>• GitHub repository:  &lt;&lt;FILL: https://github.com/USERNAME/REPO&gt;&gt;</a:t>
+                  <a:srgbClr val="1F6FB2"/>
+                </a:solidFill>
+              </a:rPr>
+              <a:t>• GitHub repository:  https://github.com/Shubham-33/evidencerank-redrob</a:t>
             </a:r>
           </a:p>
           <a:p>
@@ -3398,10 +3398,10 @@
             <a:r>
               <a:rPr sz="1600" b="1">
                 <a:solidFill>
-                  <a:srgbClr val="C0392B"/>
-                </a:solidFill>
-              </a:rPr>
-              <a:t>• Hosted sandbox / demo:  &lt;&lt;FILL: Streamlit Cloud or HuggingFace Space URL&gt;&gt;</a:t>
+                  <a:srgbClr val="1F6FB2"/>
+                </a:solidFill>
+              </a:rPr>
+              <a:t>• Hosted sandbox / demo:  https://evidencerank-redrob-owdbxcyvchuhvav5gxtvaf.streamlit.app/</a:t>
             </a:r>
           </a:p>
           <a:p>
@@ -3413,10 +3413,25 @@
             <a:r>
               <a:rPr sz="1600" b="1">
                 <a:solidFill>
-                  <a:srgbClr val="C0392B"/>
-                </a:solidFill>
-              </a:rPr>
-              <a:t>• Demo video:  &lt;&lt;FILL: video link (YouTube / Loom / Drive)&gt;&gt;</a:t>
+                  <a:srgbClr val="1F6FB2"/>
+                </a:solidFill>
+              </a:rPr>
+              <a:t>• Live demo:  the hosted Streamlit sandbox (link above) — runs the ranker on any sample.</a:t>
+            </a:r>
+          </a:p>
+          <a:p>
+            <a:pPr>
+              <a:spcAft>
+                <a:spcPts val="600"/>
+              </a:spcAft>
+            </a:pPr>
+            <a:r>
+              <a:rPr sz="1600" b="1">
+                <a:solidFill>
+                  <a:srgbClr val="1F6FB2"/>
+                </a:solidFill>
+              </a:rPr>
+              <a:t>• Walkthrough:  step-by-step usage &amp; reproduce steps in README.md.</a:t>
             </a:r>
           </a:p>
           <a:p>

</xml_diff>